<commit_message>
Records review: simpler tiles, gross profit labels, one-line heads and column rules
Co-Authored-By: Claude Opus 5.5 <noreply@anthropic.com>
Claude-Session: https://claude.ai/code/session_01Xa4nFVxuQGXmHARGph9WhS
</commit_message>
<xml_diff>
--- a/day2-deck/decks/Store Records with Net - Review.pptx
+++ b/day2-deck/decks/Store Records with Net - Review.pptx
@@ -1288,7 +1288,7 @@
                 <a:ea typeface="Inter" pitchFamily="34" charset="-122"/>
                 <a:cs typeface="Inter" pitchFamily="34" charset="-120"/>
               </a:rPr>
-              <a:t>STORES WITH ALL-TIME RECORD MONTHS</a:t>
+              <a:t>STORES WITH A RECORD MONTH</a:t>
             </a:r>
             <a:endParaRPr lang="en-US" sz="1400" dirty="0"/>
           </a:p>
@@ -1368,7 +1368,7 @@
                 <a:ea typeface="Inter" pitchFamily="34" charset="-122"/>
                 <a:cs typeface="Inter" pitchFamily="34" charset="-120"/>
               </a:rPr>
-              <a:t>of 33 set their best month ever in service, parts or combined during 2026.</a:t>
+              <a:t>of 33 had their best month ever in 2026.</a:t>
             </a:r>
             <a:endParaRPr lang="en-US" sz="1500" dirty="0"/>
           </a:p>
@@ -1447,7 +1447,7 @@
                 <a:ea typeface="Inter" pitchFamily="34" charset="-122"/>
                 <a:cs typeface="Inter" pitchFamily="34" charset="-120"/>
               </a:rPr>
-              <a:t>STORE RECORDS SET</a:t>
+              <a:t>RECORDS SET</a:t>
             </a:r>
             <a:endParaRPr lang="en-US" sz="1400" dirty="0"/>
           </a:p>
@@ -1527,7 +1527,7 @@
                 <a:ea typeface="Inter" pitchFamily="34" charset="-122"/>
                 <a:cs typeface="Inter" pitchFamily="34" charset="-120"/>
               </a:rPr>
-              <a:t>all-time monthly records across those stores: service, parts and combined counted separately.</a:t>
+              <a:t>service, parts and combined, counted separately.</a:t>
             </a:r>
             <a:endParaRPr lang="en-US" sz="1500" dirty="0"/>
           </a:p>
@@ -1606,7 +1606,7 @@
                 <a:ea typeface="Inter" pitchFamily="34" charset="-122"/>
                 <a:cs typeface="Inter" pitchFamily="34" charset="-120"/>
               </a:rPr>
-              <a:t>BEST JANUARY–SEPTEMBER EVER</a:t>
+              <a:t>BEST JAN–SEP GROSS PROFIT EVER</a:t>
             </a:r>
             <a:endParaRPr lang="en-US" sz="1400" dirty="0"/>
           </a:p>
@@ -1686,7 +1686,7 @@
                 <a:ea typeface="Inter" pitchFamily="34" charset="-122"/>
                 <a:cs typeface="Inter" pitchFamily="34" charset="-120"/>
               </a:rPr>
-              <a:t>stores had their best January–September ever in combined fixed gross.</a:t>
+              <a:t>stores, service and parts combined.</a:t>
             </a:r>
             <a:endParaRPr lang="en-US" sz="1500" dirty="0"/>
           </a:p>
@@ -1765,7 +1765,7 @@
                 <a:ea typeface="Inter" pitchFamily="34" charset="-122"/>
                 <a:cs typeface="Inter" pitchFamily="34" charset="-120"/>
               </a:rPr>
-              <a:t>STORES WHO SET A RECORD AND THEN RESET IT</a:t>
+              <a:t>RECORDS BROKEN TWICE</a:t>
             </a:r>
             <a:endParaRPr lang="en-US" sz="1400" dirty="0"/>
           </a:p>
@@ -1845,7 +1845,7 @@
                 <a:ea typeface="Inter" pitchFamily="34" charset="-122"/>
                 <a:cs typeface="Inter" pitchFamily="34" charset="-120"/>
               </a:rPr>
-              <a:t>stores set a record and then topped it again later in the year.</a:t>
+              <a:t>stores set a record, then beat it again.</a:t>
             </a:r>
             <a:endParaRPr lang="en-US" sz="1500" dirty="0"/>
           </a:p>
@@ -1924,7 +1924,7 @@
                 <a:ea typeface="Inter" pitchFamily="34" charset="-122"/>
                 <a:cs typeface="Inter" pitchFamily="34" charset="-120"/>
               </a:rPr>
-              <a:t>BEST JANUARY–SEPTEMBER NET PROFIT EVER</a:t>
+              <a:t>BEST JAN–SEP NET PROFIT EVER</a:t>
             </a:r>
             <a:endParaRPr lang="en-US" sz="1400" dirty="0"/>
           </a:p>
@@ -2004,7 +2004,7 @@
                 <a:ea typeface="Inter" pitchFamily="34" charset="-122"/>
                 <a:cs typeface="Inter" pitchFamily="34" charset="-120"/>
               </a:rPr>
-              <a:t>stores had their best January–September ever in fixed ops net profit; 18 also set the gross record.</a:t>
+              <a:t>stores; 18 also set the gross profit record.</a:t>
             </a:r>
             <a:endParaRPr lang="en-US" sz="1500" dirty="0"/>
           </a:p>
@@ -2232,7 +2232,7 @@
                 <a:ea typeface="Inter" pitchFamily="34" charset="-122"/>
                 <a:cs typeface="Inter" pitchFamily="34" charset="-120"/>
               </a:rPr>
-              <a:t>Records Set in 2026</a:t>
+              <a:t>Records Set in 2026: Gross Profit</a:t>
             </a:r>
             <a:endParaRPr lang="en-US" sz="2800" dirty="0"/>
           </a:p>
@@ -8670,23 +8670,23 @@
         <p:spPr>
           <a:xfrm>
             <a:off x="749808" y="1463040"/>
-            <a:ext cx="4229100" cy="292608"/>
-          </a:xfrm>
-          <a:prstGeom prst="rect">
-            <a:avLst/>
-          </a:prstGeom>
-          <a:noFill/>
-          <a:ln/>
-        </p:spPr>
-        <p:txBody>
-          <a:bodyPr wrap="square" lIns="0" tIns="0" rIns="0" bIns="0" rtlCol="0" anchor="ctr"/>
+            <a:ext cx="4549140" cy="292608"/>
+          </a:xfrm>
+          <a:prstGeom prst="rect">
+            <a:avLst/>
+          </a:prstGeom>
+          <a:noFill/>
+          <a:ln/>
+        </p:spPr>
+        <p:txBody>
+          <a:bodyPr wrap="none" lIns="0" tIns="0" rIns="0" bIns="0" rtlCol="0" anchor="ctr"/>
           <a:lstStyle/>
           <a:p>
             <a:pPr indent="0" marL="0">
               <a:buNone/>
             </a:pPr>
             <a:r>
-              <a:rPr lang="en-US" sz="1500" b="1" spc="100" kern="0" dirty="0">
+              <a:rPr lang="en-US" sz="1500" b="1" spc="40" kern="0" dirty="0">
                 <a:solidFill>
                   <a:srgbClr val="0B7A4A"/>
                 </a:solidFill>
@@ -8708,8 +8708,8 @@
         </p:nvSpPr>
         <p:spPr>
           <a:xfrm>
-            <a:off x="4978908" y="1408176"/>
-            <a:ext cx="822960" cy="402336"/>
+            <a:off x="5326380" y="1408176"/>
+            <a:ext cx="502920" cy="402336"/>
           </a:xfrm>
           <a:prstGeom prst="rect">
             <a:avLst/>
@@ -9172,23 +9172,23 @@
         <p:spPr>
           <a:xfrm>
             <a:off x="6185916" y="1463040"/>
-            <a:ext cx="1611630" cy="292608"/>
-          </a:xfrm>
-          <a:prstGeom prst="rect">
-            <a:avLst/>
-          </a:prstGeom>
-          <a:noFill/>
-          <a:ln/>
-        </p:spPr>
-        <p:txBody>
-          <a:bodyPr wrap="square" lIns="0" tIns="0" rIns="0" bIns="0" rtlCol="0" anchor="ctr"/>
+            <a:ext cx="1931670" cy="292608"/>
+          </a:xfrm>
+          <a:prstGeom prst="rect">
+            <a:avLst/>
+          </a:prstGeom>
+          <a:noFill/>
+          <a:ln/>
+        </p:spPr>
+        <p:txBody>
+          <a:bodyPr wrap="none" lIns="0" tIns="0" rIns="0" bIns="0" rtlCol="0" anchor="ctr"/>
           <a:lstStyle/>
           <a:p>
             <a:pPr indent="0" marL="0">
               <a:buNone/>
             </a:pPr>
             <a:r>
-              <a:rPr lang="en-US" sz="1500" b="1" spc="100" kern="0" dirty="0">
+              <a:rPr lang="en-US" sz="1500" b="1" spc="40" kern="0" dirty="0">
                 <a:solidFill>
                   <a:srgbClr val="0B2C4A"/>
                 </a:solidFill>
@@ -9196,7 +9196,7 @@
                 <a:ea typeface="Inter" pitchFamily="34" charset="-122"/>
                 <a:cs typeface="Inter" pitchFamily="34" charset="-120"/>
               </a:rPr>
-              <a:t>GROSS ONLY</a:t>
+              <a:t>GROSS PROFIT ONLY</a:t>
             </a:r>
             <a:endParaRPr lang="en-US" sz="1500" dirty="0"/>
           </a:p>
@@ -9204,14 +9204,37 @@
       </p:sp>
       <p:sp>
         <p:nvSpPr>
-          <p:cNvPr id="13" name="Text 11"/>
-          <p:cNvSpPr txBox="1"/>
-          <p:nvPr/>
-        </p:nvSpPr>
-        <p:spPr>
-          <a:xfrm>
-            <a:off x="7797546" y="1408176"/>
-            <a:ext cx="822960" cy="402336"/>
+          <p:cNvPr id="13" name="Shape 11"/>
+          <p:cNvSpPr/>
+          <p:nvPr/>
+        </p:nvSpPr>
+        <p:spPr>
+          <a:xfrm>
+            <a:off x="5993892" y="1371600"/>
+            <a:ext cx="0" cy="4526280"/>
+          </a:xfrm>
+          <a:prstGeom prst="line">
+            <a:avLst/>
+          </a:prstGeom>
+          <a:noFill/>
+          <a:ln w="9525">
+            <a:solidFill>
+              <a:srgbClr val="BFBFBF"/>
+            </a:solidFill>
+            <a:prstDash val="solid"/>
+          </a:ln>
+        </p:spPr>
+      </p:sp>
+      <p:sp>
+        <p:nvSpPr>
+          <p:cNvPr id="14" name="Text 12"/>
+          <p:cNvSpPr txBox="1"/>
+          <p:nvPr/>
+        </p:nvSpPr>
+        <p:spPr>
+          <a:xfrm>
+            <a:off x="8145018" y="1408176"/>
+            <a:ext cx="502920" cy="402336"/>
           </a:xfrm>
           <a:prstGeom prst="rect">
             <a:avLst/>
@@ -9243,7 +9266,7 @@
       </p:sp>
       <p:sp>
         <p:nvSpPr>
-          <p:cNvPr id="14" name="Text 12"/>
+          <p:cNvPr id="15" name="Text 13"/>
           <p:cNvSpPr txBox="1"/>
           <p:nvPr/>
         </p:nvSpPr>
@@ -9405,7 +9428,7 @@
       </p:sp>
       <p:sp>
         <p:nvSpPr>
-          <p:cNvPr id="15" name="Shape 13"/>
+          <p:cNvPr id="16" name="Shape 14"/>
           <p:cNvSpPr/>
           <p:nvPr/>
         </p:nvSpPr>
@@ -9425,30 +9448,30 @@
       </p:sp>
       <p:sp>
         <p:nvSpPr>
-          <p:cNvPr id="16" name="Text 14"/>
+          <p:cNvPr id="17" name="Text 15"/>
           <p:cNvSpPr txBox="1"/>
           <p:nvPr/>
         </p:nvSpPr>
         <p:spPr>
           <a:xfrm>
             <a:off x="9004554" y="1463040"/>
-            <a:ext cx="1611630" cy="292608"/>
-          </a:xfrm>
-          <a:prstGeom prst="rect">
-            <a:avLst/>
-          </a:prstGeom>
-          <a:noFill/>
-          <a:ln/>
-        </p:spPr>
-        <p:txBody>
-          <a:bodyPr wrap="square" lIns="0" tIns="0" rIns="0" bIns="0" rtlCol="0" anchor="ctr"/>
+            <a:ext cx="1931670" cy="292608"/>
+          </a:xfrm>
+          <a:prstGeom prst="rect">
+            <a:avLst/>
+          </a:prstGeom>
+          <a:noFill/>
+          <a:ln/>
+        </p:spPr>
+        <p:txBody>
+          <a:bodyPr wrap="none" lIns="0" tIns="0" rIns="0" bIns="0" rtlCol="0" anchor="ctr"/>
           <a:lstStyle/>
           <a:p>
             <a:pPr indent="0" marL="0">
               <a:buNone/>
             </a:pPr>
             <a:r>
-              <a:rPr lang="en-US" sz="1500" b="1" spc="100" kern="0" dirty="0">
+              <a:rPr lang="en-US" sz="1500" b="1" spc="40" kern="0" dirty="0">
                 <a:solidFill>
                   <a:srgbClr val="0B2C4A"/>
                 </a:solidFill>
@@ -9464,14 +9487,37 @@
       </p:sp>
       <p:sp>
         <p:nvSpPr>
-          <p:cNvPr id="17" name="Text 15"/>
-          <p:cNvSpPr txBox="1"/>
-          <p:nvPr/>
-        </p:nvSpPr>
-        <p:spPr>
-          <a:xfrm>
-            <a:off x="10616184" y="1408176"/>
-            <a:ext cx="822960" cy="402336"/>
+          <p:cNvPr id="18" name="Shape 16"/>
+          <p:cNvSpPr/>
+          <p:nvPr/>
+        </p:nvSpPr>
+        <p:spPr>
+          <a:xfrm>
+            <a:off x="8812530" y="1371600"/>
+            <a:ext cx="0" cy="4526280"/>
+          </a:xfrm>
+          <a:prstGeom prst="line">
+            <a:avLst/>
+          </a:prstGeom>
+          <a:noFill/>
+          <a:ln w="9525">
+            <a:solidFill>
+              <a:srgbClr val="BFBFBF"/>
+            </a:solidFill>
+            <a:prstDash val="solid"/>
+          </a:ln>
+        </p:spPr>
+      </p:sp>
+      <p:sp>
+        <p:nvSpPr>
+          <p:cNvPr id="19" name="Text 17"/>
+          <p:cNvSpPr txBox="1"/>
+          <p:nvPr/>
+        </p:nvSpPr>
+        <p:spPr>
+          <a:xfrm>
+            <a:off x="10963656" y="1408176"/>
+            <a:ext cx="502920" cy="402336"/>
           </a:xfrm>
           <a:prstGeom prst="rect">
             <a:avLst/>
@@ -9503,7 +9549,7 @@
       </p:sp>
       <p:sp>
         <p:nvSpPr>
-          <p:cNvPr id="18" name="Text 16"/>
+          <p:cNvPr id="20" name="Text 18"/>
           <p:cNvSpPr txBox="1"/>
           <p:nvPr/>
         </p:nvSpPr>
@@ -9585,14 +9631,14 @@
       </p:sp>
       <p:sp>
         <p:nvSpPr>
-          <p:cNvPr id="19" name="Shape 17"/>
+          <p:cNvPr id="21" name="Shape 19"/>
           <p:cNvSpPr/>
           <p:nvPr/>
         </p:nvSpPr>
         <p:spPr>
           <a:xfrm>
             <a:off x="457200" y="6126480"/>
-            <a:ext cx="11274552" cy="364236"/>
+            <a:ext cx="11274552" cy="371856"/>
           </a:xfrm>
           <a:prstGeom prst="rect">
             <a:avLst/>
@@ -9605,14 +9651,14 @@
       </p:sp>
       <p:sp>
         <p:nvSpPr>
-          <p:cNvPr id="20" name="Text 18"/>
+          <p:cNvPr id="22" name="Text 20"/>
           <p:cNvSpPr txBox="1"/>
           <p:nvPr/>
         </p:nvSpPr>
         <p:spPr>
           <a:xfrm>
             <a:off x="658368" y="6144768"/>
-            <a:ext cx="10927080" cy="327660"/>
+            <a:ext cx="10927080" cy="335280"/>
           </a:xfrm>
           <a:prstGeom prst="rect">
             <a:avLst/>
@@ -9628,7 +9674,7 @@
               <a:buNone/>
             </a:pPr>
             <a:r>
-              <a:rPr lang="en-US" sz="1550" b="1" dirty="0">
+              <a:rPr lang="en-US" sz="1600" b="1" dirty="0">
                 <a:solidFill>
                   <a:srgbClr val="0B7A4A"/>
                 </a:solidFill>
@@ -9636,9 +9682,9 @@
                 <a:ea typeface="Inter" pitchFamily="34" charset="-122"/>
                 <a:cs typeface="Inter" pitchFamily="34" charset="-120"/>
               </a:rPr>
-              <a:t>25 stores set a January–September record in fixed gross and 21 in fixed ops net profit; 18 did both.</a:t>
-            </a:r>
-            <a:endParaRPr lang="en-US" sz="1550" dirty="0"/>
+              <a:t>25 stores set a January–September record in gross profit and 21 in net profit; 18 did both.</a:t>
+            </a:r>
+            <a:endParaRPr lang="en-US" sz="1600" dirty="0"/>
           </a:p>
         </p:txBody>
       </p:sp>

</xml_diff>

<commit_message>
Records review: gross profit named on the A Record Year tiles
Co-Authored-By: Claude Opus 5.5 <noreply@anthropic.com>
Claude-Session: https://claude.ai/code/session_01Xa4nFVxuQGXmHARGph9WhS
</commit_message>
<xml_diff>
--- a/day2-deck/decks/Store Records with Net - Review.pptx
+++ b/day2-deck/decks/Store Records with Net - Review.pptx
@@ -1368,7 +1368,7 @@
                 <a:ea typeface="Inter" pitchFamily="34" charset="-122"/>
                 <a:cs typeface="Inter" pitchFamily="34" charset="-120"/>
               </a:rPr>
-              <a:t>of 33 had their best month ever in 2026.</a:t>
+              <a:t>of 33 had their best gross profit month ever in 2026.</a:t>
             </a:r>
             <a:endParaRPr lang="en-US" sz="1500" dirty="0"/>
           </a:p>
@@ -1527,7 +1527,7 @@
                 <a:ea typeface="Inter" pitchFamily="34" charset="-122"/>
                 <a:cs typeface="Inter" pitchFamily="34" charset="-120"/>
               </a:rPr>
-              <a:t>service, parts and combined, counted separately.</a:t>
+              <a:t>gross profit records in service, parts and combined.</a:t>
             </a:r>
             <a:endParaRPr lang="en-US" sz="1500" dirty="0"/>
           </a:p>
@@ -1845,7 +1845,7 @@
                 <a:ea typeface="Inter" pitchFamily="34" charset="-122"/>
                 <a:cs typeface="Inter" pitchFamily="34" charset="-120"/>
               </a:rPr>
-              <a:t>stores set a record, then beat it again.</a:t>
+              <a:t>stores set a gross profit record, then beat it again.</a:t>
             </a:r>
             <a:endParaRPr lang="en-US" sz="1500" dirty="0"/>
           </a:p>

</xml_diff>